<commit_message>
compelted ppt overall architecture
</commit_message>
<xml_diff>
--- a/prcv2026/figs/figs.pptx
+++ b/prcv2026/figs/figs.pptx
@@ -5,14 +5,13 @@
     <p:sldMasterId id="2147483648" r:id="rId1"/>
   </p:sldMasterIdLst>
   <p:notesMasterIdLst>
-    <p:notesMasterId r:id="rId5"/>
+    <p:notesMasterId r:id="rId4"/>
   </p:notesMasterIdLst>
   <p:handoutMasterIdLst>
-    <p:handoutMasterId r:id="rId6"/>
+    <p:handoutMasterId r:id="rId5"/>
   </p:handoutMasterIdLst>
   <p:sldIdLst>
-    <p:sldId id="256" r:id="rId3"/>
-    <p:sldId id="257" r:id="rId4"/>
+    <p:sldId id="257" r:id="rId3"/>
   </p:sldIdLst>
   <p:sldSz cx="12192000" cy="6858000"/>
   <p:notesSz cx="6858000" cy="9144000"/>
@@ -119,7 +118,7 @@
             <a:srgbClr val="A4A3A4"/>
           </p15:clr>
         </p15:guide>
-        <p15:guide id="2" pos="3885" userDrawn="1">
+        <p15:guide id="2" pos="3907" userDrawn="1">
           <p15:clr>
             <a:srgbClr val="A4A3A4"/>
           </p15:clr>
@@ -3583,514 +3582,6 @@
         <p:cNvGrpSpPr/>
         <p:nvPr/>
       </p:nvGrpSpPr>
-      <p:grpSpPr>
-        <a:xfrm>
-          <a:off x="0" y="0"/>
-          <a:ext cx="0" cy="0"/>
-          <a:chOff x="0" y="0"/>
-          <a:chExt cx="0" cy="0"/>
-        </a:xfrm>
-      </p:grpSpPr>
-      <p:sp>
-        <p:nvSpPr>
-          <p:cNvPr id="2" name="圆角矩形 1"/>
-          <p:cNvSpPr/>
-          <p:nvPr/>
-        </p:nvSpPr>
-        <p:spPr>
-          <a:xfrm>
-            <a:off x="544195" y="1281430"/>
-            <a:ext cx="609600" cy="1440180"/>
-          </a:xfrm>
-          <a:prstGeom prst="roundRect">
-            <a:avLst/>
-          </a:prstGeom>
-          <a:solidFill>
-            <a:schemeClr val="accent2">
-              <a:lumMod val="20000"/>
-              <a:lumOff val="80000"/>
-            </a:schemeClr>
-          </a:solidFill>
-          <a:ln>
-            <a:solidFill>
-              <a:schemeClr val="tx1"/>
-            </a:solidFill>
-          </a:ln>
-        </p:spPr>
-        <p:style>
-          <a:lnRef idx="2">
-            <a:schemeClr val="accent1">
-              <a:lumMod val="75000"/>
-            </a:schemeClr>
-          </a:lnRef>
-          <a:fillRef idx="1">
-            <a:schemeClr val="accent1"/>
-          </a:fillRef>
-          <a:effectRef idx="0">
-            <a:srgbClr val="FFFFFF"/>
-          </a:effectRef>
-          <a:fontRef idx="minor">
-            <a:schemeClr val="lt1"/>
-          </a:fontRef>
-        </p:style>
-        <p:txBody>
-          <a:bodyPr rtlCol="0" anchor="ctr"/>
-          <a:p>
-            <a:pPr algn="ctr"/>
-            <a:r>
-              <a:rPr lang="en-US" altLang="zh-CN" sz="1000">
-                <a:solidFill>
-                  <a:schemeClr val="tx1"/>
-                </a:solidFill>
-                <a:latin typeface="Times New Roman" panose="02020503050405090304" charset="0"/>
-                <a:cs typeface="Times New Roman" panose="02020503050405090304" charset="0"/>
-              </a:rPr>
-              <a:t>SS2D</a:t>
-            </a:r>
-            <a:endParaRPr lang="en-US" altLang="zh-CN" sz="1000">
-              <a:solidFill>
-                <a:schemeClr val="tx1"/>
-              </a:solidFill>
-              <a:latin typeface="Times New Roman" panose="02020503050405090304" charset="0"/>
-              <a:cs typeface="Times New Roman" panose="02020503050405090304" charset="0"/>
-            </a:endParaRPr>
-          </a:p>
-          <a:p>
-            <a:pPr algn="ctr"/>
-            <a:r>
-              <a:rPr lang="en-US" altLang="zh-CN" sz="1000">
-                <a:solidFill>
-                  <a:schemeClr val="tx1"/>
-                </a:solidFill>
-                <a:latin typeface="Times New Roman" panose="02020503050405090304" charset="0"/>
-                <a:cs typeface="Times New Roman" panose="02020503050405090304" charset="0"/>
-              </a:rPr>
-              <a:t>*2</a:t>
-            </a:r>
-            <a:endParaRPr lang="en-US" altLang="zh-CN" sz="1000">
-              <a:solidFill>
-                <a:schemeClr val="tx1"/>
-              </a:solidFill>
-              <a:latin typeface="Times New Roman" panose="02020503050405090304" charset="0"/>
-              <a:cs typeface="Times New Roman" panose="02020503050405090304" charset="0"/>
-            </a:endParaRPr>
-          </a:p>
-          <a:p>
-            <a:pPr algn="ctr"/>
-            <a:endParaRPr lang="en-US" altLang="zh-CN" sz="1000">
-              <a:solidFill>
-                <a:schemeClr val="tx1"/>
-              </a:solidFill>
-              <a:latin typeface="Times New Roman" panose="02020503050405090304" charset="0"/>
-              <a:cs typeface="Times New Roman" panose="02020503050405090304" charset="0"/>
-            </a:endParaRPr>
-          </a:p>
-        </p:txBody>
-      </p:sp>
-      <p:sp>
-        <p:nvSpPr>
-          <p:cNvPr id="8" name="圆角矩形 7"/>
-          <p:cNvSpPr/>
-          <p:nvPr/>
-        </p:nvSpPr>
-        <p:spPr>
-          <a:xfrm>
-            <a:off x="1478915" y="1281430"/>
-            <a:ext cx="609600" cy="1440180"/>
-          </a:xfrm>
-          <a:prstGeom prst="roundRect">
-            <a:avLst/>
-          </a:prstGeom>
-          <a:solidFill>
-            <a:schemeClr val="accent2">
-              <a:lumMod val="20000"/>
-              <a:lumOff val="80000"/>
-            </a:schemeClr>
-          </a:solidFill>
-          <a:ln>
-            <a:solidFill>
-              <a:schemeClr val="tx1"/>
-            </a:solidFill>
-          </a:ln>
-        </p:spPr>
-        <p:style>
-          <a:lnRef idx="2">
-            <a:schemeClr val="accent1">
-              <a:lumMod val="75000"/>
-            </a:schemeClr>
-          </a:lnRef>
-          <a:fillRef idx="1">
-            <a:schemeClr val="accent1"/>
-          </a:fillRef>
-          <a:effectRef idx="0">
-            <a:srgbClr val="FFFFFF"/>
-          </a:effectRef>
-          <a:fontRef idx="minor">
-            <a:schemeClr val="lt1"/>
-          </a:fontRef>
-        </p:style>
-        <p:txBody>
-          <a:bodyPr rtlCol="0" anchor="ctr"/>
-          <a:p>
-            <a:pPr algn="ctr"/>
-            <a:r>
-              <a:rPr lang="en-US" altLang="zh-CN" sz="1000">
-                <a:solidFill>
-                  <a:schemeClr val="tx1"/>
-                </a:solidFill>
-                <a:latin typeface="Times New Roman" panose="02020503050405090304" charset="0"/>
-                <a:cs typeface="Times New Roman" panose="02020503050405090304" charset="0"/>
-              </a:rPr>
-              <a:t>SS2D</a:t>
-            </a:r>
-            <a:endParaRPr lang="en-US" altLang="zh-CN" sz="1000">
-              <a:solidFill>
-                <a:schemeClr val="tx1"/>
-              </a:solidFill>
-              <a:latin typeface="Times New Roman" panose="02020503050405090304" charset="0"/>
-              <a:cs typeface="Times New Roman" panose="02020503050405090304" charset="0"/>
-            </a:endParaRPr>
-          </a:p>
-          <a:p>
-            <a:pPr algn="ctr"/>
-            <a:r>
-              <a:rPr lang="en-US" altLang="zh-CN" sz="1000">
-                <a:solidFill>
-                  <a:schemeClr val="tx1"/>
-                </a:solidFill>
-                <a:latin typeface="Times New Roman" panose="02020503050405090304" charset="0"/>
-                <a:cs typeface="Times New Roman" panose="02020503050405090304" charset="0"/>
-              </a:rPr>
-              <a:t>*2</a:t>
-            </a:r>
-            <a:endParaRPr lang="en-US" altLang="zh-CN" sz="1000">
-              <a:solidFill>
-                <a:schemeClr val="tx1"/>
-              </a:solidFill>
-              <a:latin typeface="Times New Roman" panose="02020503050405090304" charset="0"/>
-              <a:cs typeface="Times New Roman" panose="02020503050405090304" charset="0"/>
-            </a:endParaRPr>
-          </a:p>
-          <a:p>
-            <a:pPr algn="ctr"/>
-            <a:endParaRPr lang="en-US" altLang="zh-CN" sz="1000">
-              <a:solidFill>
-                <a:schemeClr val="tx1"/>
-              </a:solidFill>
-              <a:latin typeface="Times New Roman" panose="02020503050405090304" charset="0"/>
-              <a:cs typeface="Times New Roman" panose="02020503050405090304" charset="0"/>
-            </a:endParaRPr>
-          </a:p>
-        </p:txBody>
-      </p:sp>
-      <p:sp>
-        <p:nvSpPr>
-          <p:cNvPr id="9" name="圆角矩形 8"/>
-          <p:cNvSpPr/>
-          <p:nvPr/>
-        </p:nvSpPr>
-        <p:spPr>
-          <a:xfrm>
-            <a:off x="2413635" y="1281430"/>
-            <a:ext cx="609600" cy="1440180"/>
-          </a:xfrm>
-          <a:prstGeom prst="roundRect">
-            <a:avLst/>
-          </a:prstGeom>
-          <a:solidFill>
-            <a:schemeClr val="accent2">
-              <a:lumMod val="20000"/>
-              <a:lumOff val="80000"/>
-            </a:schemeClr>
-          </a:solidFill>
-          <a:ln>
-            <a:solidFill>
-              <a:schemeClr val="tx1"/>
-            </a:solidFill>
-          </a:ln>
-        </p:spPr>
-        <p:style>
-          <a:lnRef idx="2">
-            <a:schemeClr val="accent1">
-              <a:lumMod val="75000"/>
-            </a:schemeClr>
-          </a:lnRef>
-          <a:fillRef idx="1">
-            <a:schemeClr val="accent1"/>
-          </a:fillRef>
-          <a:effectRef idx="0">
-            <a:srgbClr val="FFFFFF"/>
-          </a:effectRef>
-          <a:fontRef idx="minor">
-            <a:schemeClr val="lt1"/>
-          </a:fontRef>
-        </p:style>
-        <p:txBody>
-          <a:bodyPr rtlCol="0" anchor="ctr"/>
-          <a:p>
-            <a:pPr algn="ctr"/>
-            <a:r>
-              <a:rPr lang="en-US" altLang="zh-CN" sz="1000">
-                <a:solidFill>
-                  <a:schemeClr val="tx1"/>
-                </a:solidFill>
-                <a:latin typeface="Times New Roman" panose="02020503050405090304" charset="0"/>
-                <a:cs typeface="Times New Roman" panose="02020503050405090304" charset="0"/>
-              </a:rPr>
-              <a:t>SS2D</a:t>
-            </a:r>
-            <a:endParaRPr lang="en-US" altLang="zh-CN" sz="1000">
-              <a:solidFill>
-                <a:schemeClr val="tx1"/>
-              </a:solidFill>
-              <a:latin typeface="Times New Roman" panose="02020503050405090304" charset="0"/>
-              <a:cs typeface="Times New Roman" panose="02020503050405090304" charset="0"/>
-            </a:endParaRPr>
-          </a:p>
-          <a:p>
-            <a:pPr algn="ctr"/>
-            <a:r>
-              <a:rPr lang="en-US" altLang="zh-CN" sz="1000">
-                <a:solidFill>
-                  <a:schemeClr val="tx1"/>
-                </a:solidFill>
-                <a:latin typeface="Times New Roman" panose="02020503050405090304" charset="0"/>
-                <a:cs typeface="Times New Roman" panose="02020503050405090304" charset="0"/>
-              </a:rPr>
-              <a:t>*2</a:t>
-            </a:r>
-            <a:endParaRPr lang="en-US" altLang="zh-CN" sz="1000">
-              <a:solidFill>
-                <a:schemeClr val="tx1"/>
-              </a:solidFill>
-              <a:latin typeface="Times New Roman" panose="02020503050405090304" charset="0"/>
-              <a:cs typeface="Times New Roman" panose="02020503050405090304" charset="0"/>
-            </a:endParaRPr>
-          </a:p>
-          <a:p>
-            <a:pPr algn="ctr"/>
-            <a:endParaRPr lang="en-US" altLang="zh-CN" sz="1000">
-              <a:solidFill>
-                <a:schemeClr val="tx1"/>
-              </a:solidFill>
-              <a:latin typeface="Times New Roman" panose="02020503050405090304" charset="0"/>
-              <a:cs typeface="Times New Roman" panose="02020503050405090304" charset="0"/>
-            </a:endParaRPr>
-          </a:p>
-        </p:txBody>
-      </p:sp>
-      <p:sp>
-        <p:nvSpPr>
-          <p:cNvPr id="10" name="圆角矩形 9"/>
-          <p:cNvSpPr/>
-          <p:nvPr/>
-        </p:nvSpPr>
-        <p:spPr>
-          <a:xfrm>
-            <a:off x="3348355" y="1281430"/>
-            <a:ext cx="609600" cy="1440180"/>
-          </a:xfrm>
-          <a:prstGeom prst="roundRect">
-            <a:avLst/>
-          </a:prstGeom>
-          <a:solidFill>
-            <a:schemeClr val="accent2">
-              <a:lumMod val="20000"/>
-              <a:lumOff val="80000"/>
-            </a:schemeClr>
-          </a:solidFill>
-          <a:ln>
-            <a:solidFill>
-              <a:schemeClr val="tx1"/>
-            </a:solidFill>
-          </a:ln>
-        </p:spPr>
-        <p:style>
-          <a:lnRef idx="2">
-            <a:schemeClr val="accent1">
-              <a:lumMod val="75000"/>
-            </a:schemeClr>
-          </a:lnRef>
-          <a:fillRef idx="1">
-            <a:schemeClr val="accent1"/>
-          </a:fillRef>
-          <a:effectRef idx="0">
-            <a:srgbClr val="FFFFFF"/>
-          </a:effectRef>
-          <a:fontRef idx="minor">
-            <a:schemeClr val="lt1"/>
-          </a:fontRef>
-        </p:style>
-        <p:txBody>
-          <a:bodyPr rtlCol="0" anchor="ctr"/>
-          <a:p>
-            <a:pPr algn="ctr"/>
-            <a:r>
-              <a:rPr lang="en-US" altLang="zh-CN" sz="1000">
-                <a:solidFill>
-                  <a:schemeClr val="tx1"/>
-                </a:solidFill>
-                <a:latin typeface="Times New Roman" panose="02020503050405090304" charset="0"/>
-                <a:cs typeface="Times New Roman" panose="02020503050405090304" charset="0"/>
-              </a:rPr>
-              <a:t>SS2D</a:t>
-            </a:r>
-            <a:endParaRPr lang="en-US" altLang="zh-CN" sz="1000">
-              <a:solidFill>
-                <a:schemeClr val="tx1"/>
-              </a:solidFill>
-              <a:latin typeface="Times New Roman" panose="02020503050405090304" charset="0"/>
-              <a:cs typeface="Times New Roman" panose="02020503050405090304" charset="0"/>
-            </a:endParaRPr>
-          </a:p>
-          <a:p>
-            <a:pPr algn="ctr"/>
-            <a:r>
-              <a:rPr lang="en-US" altLang="zh-CN" sz="1000">
-                <a:solidFill>
-                  <a:schemeClr val="tx1"/>
-                </a:solidFill>
-                <a:latin typeface="Times New Roman" panose="02020503050405090304" charset="0"/>
-                <a:cs typeface="Times New Roman" panose="02020503050405090304" charset="0"/>
-              </a:rPr>
-              <a:t>*2</a:t>
-            </a:r>
-            <a:endParaRPr lang="en-US" altLang="zh-CN" sz="1000">
-              <a:solidFill>
-                <a:schemeClr val="tx1"/>
-              </a:solidFill>
-              <a:latin typeface="Times New Roman" panose="02020503050405090304" charset="0"/>
-              <a:cs typeface="Times New Roman" panose="02020503050405090304" charset="0"/>
-            </a:endParaRPr>
-          </a:p>
-          <a:p>
-            <a:pPr algn="ctr"/>
-            <a:endParaRPr lang="en-US" altLang="zh-CN" sz="1000">
-              <a:solidFill>
-                <a:schemeClr val="tx1"/>
-              </a:solidFill>
-              <a:latin typeface="Times New Roman" panose="02020503050405090304" charset="0"/>
-              <a:cs typeface="Times New Roman" panose="02020503050405090304" charset="0"/>
-            </a:endParaRPr>
-          </a:p>
-        </p:txBody>
-      </p:sp>
-      <p:sp>
-        <p:nvSpPr>
-          <p:cNvPr id="11" name="圆角矩形 10"/>
-          <p:cNvSpPr/>
-          <p:nvPr/>
-        </p:nvSpPr>
-        <p:spPr>
-          <a:xfrm>
-            <a:off x="4845685" y="1281430"/>
-            <a:ext cx="609600" cy="1440180"/>
-          </a:xfrm>
-          <a:prstGeom prst="roundRect">
-            <a:avLst/>
-          </a:prstGeom>
-          <a:solidFill>
-            <a:schemeClr val="accent2">
-              <a:lumMod val="20000"/>
-              <a:lumOff val="80000"/>
-            </a:schemeClr>
-          </a:solidFill>
-          <a:ln>
-            <a:solidFill>
-              <a:schemeClr val="tx1"/>
-            </a:solidFill>
-          </a:ln>
-        </p:spPr>
-        <p:style>
-          <a:lnRef idx="2">
-            <a:schemeClr val="accent1">
-              <a:lumMod val="75000"/>
-            </a:schemeClr>
-          </a:lnRef>
-          <a:fillRef idx="1">
-            <a:schemeClr val="accent1"/>
-          </a:fillRef>
-          <a:effectRef idx="0">
-            <a:srgbClr val="FFFFFF"/>
-          </a:effectRef>
-          <a:fontRef idx="minor">
-            <a:schemeClr val="lt1"/>
-          </a:fontRef>
-        </p:style>
-        <p:txBody>
-          <a:bodyPr rtlCol="0" anchor="ctr"/>
-          <a:p>
-            <a:pPr algn="ctr"/>
-            <a:r>
-              <a:rPr lang="en-US" altLang="zh-CN" sz="1000">
-                <a:solidFill>
-                  <a:schemeClr val="tx1"/>
-                </a:solidFill>
-                <a:latin typeface="Times New Roman" panose="02020503050405090304" charset="0"/>
-                <a:cs typeface="Times New Roman" panose="02020503050405090304" charset="0"/>
-              </a:rPr>
-              <a:t>SS2D</a:t>
-            </a:r>
-            <a:endParaRPr lang="en-US" altLang="zh-CN" sz="1000">
-              <a:solidFill>
-                <a:schemeClr val="tx1"/>
-              </a:solidFill>
-              <a:latin typeface="Times New Roman" panose="02020503050405090304" charset="0"/>
-              <a:cs typeface="Times New Roman" panose="02020503050405090304" charset="0"/>
-            </a:endParaRPr>
-          </a:p>
-          <a:p>
-            <a:pPr algn="ctr"/>
-            <a:r>
-              <a:rPr lang="en-US" altLang="zh-CN" sz="1000">
-                <a:solidFill>
-                  <a:schemeClr val="tx1"/>
-                </a:solidFill>
-                <a:latin typeface="Times New Roman" panose="02020503050405090304" charset="0"/>
-                <a:cs typeface="Times New Roman" panose="02020503050405090304" charset="0"/>
-              </a:rPr>
-              <a:t>*2</a:t>
-            </a:r>
-            <a:endParaRPr lang="en-US" altLang="zh-CN" sz="1000">
-              <a:solidFill>
-                <a:schemeClr val="tx1"/>
-              </a:solidFill>
-              <a:latin typeface="Times New Roman" panose="02020503050405090304" charset="0"/>
-              <a:cs typeface="Times New Roman" panose="02020503050405090304" charset="0"/>
-            </a:endParaRPr>
-          </a:p>
-          <a:p>
-            <a:pPr algn="ctr"/>
-            <a:endParaRPr lang="en-US" altLang="zh-CN" sz="1000">
-              <a:solidFill>
-                <a:schemeClr val="tx1"/>
-              </a:solidFill>
-              <a:latin typeface="Times New Roman" panose="02020503050405090304" charset="0"/>
-              <a:cs typeface="Times New Roman" panose="02020503050405090304" charset="0"/>
-            </a:endParaRPr>
-          </a:p>
-        </p:txBody>
-      </p:sp>
-    </p:spTree>
-    <p:custDataLst>
-      <p:tags r:id="rId1"/>
-    </p:custDataLst>
-  </p:cSld>
-  <p:clrMapOvr>
-    <a:masterClrMapping/>
-  </p:clrMapOvr>
-</p:sld>
-</file>
-
-<file path=ppt/slides/slide2.xml><?xml version="1.0" encoding="utf-8"?>
-<p:sld xmlns:a="http://schemas.openxmlformats.org/drawingml/2006/main" xmlns:r="http://schemas.openxmlformats.org/officeDocument/2006/relationships" xmlns:p="http://schemas.openxmlformats.org/presentationml/2006/main">
-  <p:cSld>
-    <p:spTree>
-      <p:nvGrpSpPr>
-        <p:cNvPr id="1" name=""/>
-        <p:cNvGrpSpPr/>
-        <p:nvPr/>
-      </p:nvGrpSpPr>
       <p:grpSpPr/>
       <p:sp>
         <p:nvSpPr>
@@ -5031,14 +4522,13 @@
           <p:cNvPr id="152" name="直接箭头连接符 151"/>
           <p:cNvCxnSpPr>
             <a:stCxn id="135" idx="2"/>
-            <a:endCxn id="10" idx="2"/>
           </p:cNvCxnSpPr>
           <p:nvPr/>
         </p:nvCxnSpPr>
         <p:spPr>
           <a:xfrm>
             <a:off x="4954905" y="3439160"/>
-            <a:ext cx="219075" cy="0"/>
+            <a:ext cx="222250" cy="0"/>
           </a:xfrm>
           <a:prstGeom prst="straightConnector1">
             <a:avLst/>
@@ -5500,7 +4990,7 @@
         </p:nvSpPr>
         <p:spPr>
           <a:xfrm>
-            <a:off x="7088505" y="2499995"/>
+            <a:off x="7114540" y="2468880"/>
             <a:ext cx="297815" cy="303530"/>
           </a:xfrm>
           <a:prstGeom prst="flowChartOr">
@@ -5539,6 +5029,619 @@
           </a:p>
         </p:txBody>
       </p:sp>
+      <p:sp>
+        <p:nvSpPr>
+          <p:cNvPr id="172" name="圆角矩形 171"/>
+          <p:cNvSpPr/>
+          <p:nvPr/>
+        </p:nvSpPr>
+        <p:spPr>
+          <a:xfrm rot="5400000">
+            <a:off x="7656830" y="1618615"/>
+            <a:ext cx="818515" cy="377825"/>
+          </a:xfrm>
+          <a:prstGeom prst="roundRect">
+            <a:avLst/>
+          </a:prstGeom>
+          <a:solidFill>
+            <a:schemeClr val="accent3"/>
+          </a:solidFill>
+          <a:ln>
+            <a:solidFill>
+              <a:schemeClr val="tx1"/>
+            </a:solidFill>
+          </a:ln>
+        </p:spPr>
+        <p:style>
+          <a:lnRef idx="2">
+            <a:schemeClr val="accent1">
+              <a:lumMod val="75000"/>
+            </a:schemeClr>
+          </a:lnRef>
+          <a:fillRef idx="1">
+            <a:schemeClr val="accent1"/>
+          </a:fillRef>
+          <a:effectRef idx="0">
+            <a:srgbClr val="FFFFFF"/>
+          </a:effectRef>
+          <a:fontRef idx="minor">
+            <a:schemeClr val="lt1"/>
+          </a:fontRef>
+        </p:style>
+        <p:txBody>
+          <a:bodyPr rtlCol="0" anchor="ctr"/>
+          <a:p>
+            <a:pPr algn="ctr"/>
+            <a:r>
+              <a:rPr lang="en-US" altLang="zh-CN" sz="800">
+                <a:solidFill>
+                  <a:schemeClr val="tx1"/>
+                </a:solidFill>
+                <a:latin typeface="Times New Roman" panose="02020503050405090304" charset="0"/>
+                <a:cs typeface="Times New Roman" panose="02020503050405090304" charset="0"/>
+              </a:rPr>
+              <a:t>MS-CCSM</a:t>
+            </a:r>
+            <a:endParaRPr lang="en-US" altLang="zh-CN" sz="800">
+              <a:solidFill>
+                <a:schemeClr val="tx1"/>
+              </a:solidFill>
+              <a:latin typeface="Times New Roman" panose="02020503050405090304" charset="0"/>
+              <a:cs typeface="Times New Roman" panose="02020503050405090304" charset="0"/>
+            </a:endParaRPr>
+          </a:p>
+        </p:txBody>
+      </p:sp>
+      <p:sp>
+        <p:nvSpPr>
+          <p:cNvPr id="173" name="圆角矩形 172"/>
+          <p:cNvSpPr/>
+          <p:nvPr/>
+        </p:nvSpPr>
+        <p:spPr>
+          <a:xfrm rot="5400000">
+            <a:off x="7279005" y="1618615"/>
+            <a:ext cx="818515" cy="377825"/>
+          </a:xfrm>
+          <a:prstGeom prst="roundRect">
+            <a:avLst/>
+          </a:prstGeom>
+          <a:solidFill>
+            <a:schemeClr val="accent3">
+              <a:alpha val="50000"/>
+            </a:schemeClr>
+          </a:solidFill>
+          <a:ln>
+            <a:solidFill>
+              <a:schemeClr val="tx1"/>
+            </a:solidFill>
+          </a:ln>
+        </p:spPr>
+        <p:style>
+          <a:lnRef idx="2">
+            <a:schemeClr val="accent1">
+              <a:lumMod val="75000"/>
+            </a:schemeClr>
+          </a:lnRef>
+          <a:fillRef idx="1">
+            <a:schemeClr val="accent1"/>
+          </a:fillRef>
+          <a:effectRef idx="0">
+            <a:srgbClr val="FFFFFF"/>
+          </a:effectRef>
+          <a:fontRef idx="minor">
+            <a:schemeClr val="lt1"/>
+          </a:fontRef>
+        </p:style>
+        <p:txBody>
+          <a:bodyPr rtlCol="0" anchor="ctr"/>
+          <a:p>
+            <a:pPr algn="ctr"/>
+            <a:r>
+              <a:rPr lang="en-US" altLang="zh-CN" sz="900">
+                <a:solidFill>
+                  <a:schemeClr val="tx1"/>
+                </a:solidFill>
+                <a:latin typeface="Times New Roman" panose="02020503050405090304" charset="0"/>
+                <a:cs typeface="Times New Roman" panose="02020503050405090304" charset="0"/>
+              </a:rPr>
+              <a:t>Patch Expanding</a:t>
+            </a:r>
+            <a:endParaRPr lang="en-US" altLang="zh-CN" sz="900">
+              <a:solidFill>
+                <a:schemeClr val="tx1"/>
+              </a:solidFill>
+              <a:latin typeface="Times New Roman" panose="02020503050405090304" charset="0"/>
+              <a:cs typeface="Times New Roman" panose="02020503050405090304" charset="0"/>
+            </a:endParaRPr>
+          </a:p>
+        </p:txBody>
+      </p:sp>
+      <p:sp>
+        <p:nvSpPr>
+          <p:cNvPr id="174" name="圆角矩形 173"/>
+          <p:cNvSpPr/>
+          <p:nvPr/>
+        </p:nvSpPr>
+        <p:spPr>
+          <a:xfrm>
+            <a:off x="7656830" y="800100"/>
+            <a:ext cx="818515" cy="377825"/>
+          </a:xfrm>
+          <a:prstGeom prst="roundRect">
+            <a:avLst/>
+          </a:prstGeom>
+          <a:solidFill>
+            <a:schemeClr val="accent1">
+              <a:lumMod val="20000"/>
+              <a:lumOff val="80000"/>
+            </a:schemeClr>
+          </a:solidFill>
+          <a:ln>
+            <a:solidFill>
+              <a:schemeClr val="tx1"/>
+            </a:solidFill>
+          </a:ln>
+        </p:spPr>
+        <p:style>
+          <a:lnRef idx="2">
+            <a:schemeClr val="accent1">
+              <a:lumMod val="75000"/>
+            </a:schemeClr>
+          </a:lnRef>
+          <a:fillRef idx="1">
+            <a:schemeClr val="accent1"/>
+          </a:fillRef>
+          <a:effectRef idx="0">
+            <a:srgbClr val="FFFFFF"/>
+          </a:effectRef>
+          <a:fontRef idx="minor">
+            <a:schemeClr val="lt1"/>
+          </a:fontRef>
+        </p:style>
+        <p:txBody>
+          <a:bodyPr rtlCol="0" anchor="ctr"/>
+          <a:p>
+            <a:pPr algn="ctr"/>
+            <a:r>
+              <a:rPr lang="en-US" altLang="zh-CN" sz="1000">
+                <a:solidFill>
+                  <a:schemeClr val="tx1"/>
+                </a:solidFill>
+                <a:latin typeface="Times New Roman" panose="02020503050405090304" charset="0"/>
+                <a:cs typeface="Times New Roman" panose="02020503050405090304" charset="0"/>
+              </a:rPr>
+              <a:t>CG</a:t>
+            </a:r>
+            <a:endParaRPr lang="en-US" altLang="zh-CN" sz="1000">
+              <a:solidFill>
+                <a:schemeClr val="tx1"/>
+              </a:solidFill>
+              <a:latin typeface="Times New Roman" panose="02020503050405090304" charset="0"/>
+              <a:cs typeface="Times New Roman" panose="02020503050405090304" charset="0"/>
+            </a:endParaRPr>
+          </a:p>
+        </p:txBody>
+      </p:sp>
+      <p:cxnSp>
+        <p:nvCxnSpPr>
+          <p:cNvPr id="175" name="直接箭头连接符 174"/>
+          <p:cNvCxnSpPr/>
+          <p:nvPr/>
+        </p:nvCxnSpPr>
+        <p:spPr>
+          <a:xfrm flipV="1">
+            <a:off x="8065135" y="1185545"/>
+            <a:ext cx="0" cy="218440"/>
+          </a:xfrm>
+          <a:prstGeom prst="straightConnector1">
+            <a:avLst/>
+          </a:prstGeom>
+          <a:ln>
+            <a:solidFill>
+              <a:schemeClr val="tx1"/>
+            </a:solidFill>
+            <a:prstDash val="sysDash"/>
+            <a:tailEnd type="arrow"/>
+          </a:ln>
+        </p:spPr>
+        <p:style>
+          <a:lnRef idx="2">
+            <a:schemeClr val="accent1"/>
+          </a:lnRef>
+          <a:fillRef idx="0">
+            <a:srgbClr val="FFFFFF"/>
+          </a:fillRef>
+          <a:effectRef idx="0">
+            <a:srgbClr val="FFFFFF"/>
+          </a:effectRef>
+          <a:fontRef idx="minor">
+            <a:schemeClr val="tx1"/>
+          </a:fontRef>
+        </p:style>
+      </p:cxnSp>
+      <p:sp>
+        <p:nvSpPr>
+          <p:cNvPr id="176" name="流程图: 或者 175"/>
+          <p:cNvSpPr/>
+          <p:nvPr/>
+        </p:nvSpPr>
+        <p:spPr>
+          <a:xfrm>
+            <a:off x="8469630" y="1687195"/>
+            <a:ext cx="297815" cy="303530"/>
+          </a:xfrm>
+          <a:prstGeom prst="flowChartOr">
+            <a:avLst/>
+          </a:prstGeom>
+          <a:solidFill>
+            <a:schemeClr val="bg1"/>
+          </a:solidFill>
+          <a:ln w="19050">
+            <a:solidFill>
+              <a:schemeClr val="tx1"/>
+            </a:solidFill>
+          </a:ln>
+        </p:spPr>
+        <p:style>
+          <a:lnRef idx="2">
+            <a:schemeClr val="accent1">
+              <a:lumMod val="75000"/>
+            </a:schemeClr>
+          </a:lnRef>
+          <a:fillRef idx="1">
+            <a:schemeClr val="accent1"/>
+          </a:fillRef>
+          <a:effectRef idx="0">
+            <a:srgbClr val="FFFFFF"/>
+          </a:effectRef>
+          <a:fontRef idx="minor">
+            <a:schemeClr val="lt1"/>
+          </a:fontRef>
+        </p:style>
+        <p:txBody>
+          <a:bodyPr rtlCol="0" anchor="ctr"/>
+          <a:p>
+            <a:pPr algn="ctr"/>
+            <a:endParaRPr lang="zh-CN" altLang="en-US"/>
+          </a:p>
+        </p:txBody>
+      </p:sp>
+      <p:cxnSp>
+        <p:nvCxnSpPr>
+          <p:cNvPr id="177" name="直接箭头连接符 176"/>
+          <p:cNvCxnSpPr>
+            <a:stCxn id="153" idx="0"/>
+            <a:endCxn id="171" idx="2"/>
+          </p:cNvCxnSpPr>
+          <p:nvPr/>
+        </p:nvCxnSpPr>
+        <p:spPr>
+          <a:xfrm>
+            <a:off x="6899910" y="2620645"/>
+            <a:ext cx="214630" cy="0"/>
+          </a:xfrm>
+          <a:prstGeom prst="straightConnector1">
+            <a:avLst/>
+          </a:prstGeom>
+          <a:ln>
+            <a:solidFill>
+              <a:schemeClr val="tx1"/>
+            </a:solidFill>
+            <a:tailEnd type="arrow"/>
+          </a:ln>
+        </p:spPr>
+        <p:style>
+          <a:lnRef idx="2">
+            <a:schemeClr val="accent1"/>
+          </a:lnRef>
+          <a:fillRef idx="0">
+            <a:srgbClr val="FFFFFF"/>
+          </a:fillRef>
+          <a:effectRef idx="0">
+            <a:srgbClr val="FFFFFF"/>
+          </a:effectRef>
+          <a:fontRef idx="minor">
+            <a:schemeClr val="tx1"/>
+          </a:fontRef>
+        </p:style>
+      </p:cxnSp>
+      <p:cxnSp>
+        <p:nvCxnSpPr>
+          <p:cNvPr id="178" name="肘形连接符 177"/>
+          <p:cNvCxnSpPr>
+            <a:stCxn id="167" idx="3"/>
+            <a:endCxn id="171" idx="0"/>
+          </p:cNvCxnSpPr>
+          <p:nvPr/>
+        </p:nvCxnSpPr>
+        <p:spPr>
+          <a:xfrm>
+            <a:off x="7120255" y="1802130"/>
+            <a:ext cx="143510" cy="666750"/>
+          </a:xfrm>
+          <a:prstGeom prst="bentConnector2">
+            <a:avLst/>
+          </a:prstGeom>
+          <a:ln>
+            <a:solidFill>
+              <a:schemeClr val="tx1"/>
+            </a:solidFill>
+            <a:tailEnd type="arrow"/>
+          </a:ln>
+        </p:spPr>
+        <p:style>
+          <a:lnRef idx="2">
+            <a:schemeClr val="accent1"/>
+          </a:lnRef>
+          <a:fillRef idx="0">
+            <a:srgbClr val="FFFFFF"/>
+          </a:fillRef>
+          <a:effectRef idx="0">
+            <a:srgbClr val="FFFFFF"/>
+          </a:effectRef>
+          <a:fontRef idx="minor">
+            <a:schemeClr val="tx1"/>
+          </a:fontRef>
+        </p:style>
+      </p:cxnSp>
+      <p:cxnSp>
+        <p:nvCxnSpPr>
+          <p:cNvPr id="179" name="肘形连接符 178"/>
+          <p:cNvCxnSpPr>
+            <a:stCxn id="171" idx="6"/>
+            <a:endCxn id="173" idx="3"/>
+          </p:cNvCxnSpPr>
+          <p:nvPr/>
+        </p:nvCxnSpPr>
+        <p:spPr>
+          <a:xfrm flipV="1">
+            <a:off x="7412355" y="2216785"/>
+            <a:ext cx="276225" cy="403860"/>
+          </a:xfrm>
+          <a:prstGeom prst="bentConnector2">
+            <a:avLst/>
+          </a:prstGeom>
+          <a:ln>
+            <a:solidFill>
+              <a:schemeClr val="tx1"/>
+            </a:solidFill>
+            <a:tailEnd type="arrow"/>
+          </a:ln>
+        </p:spPr>
+        <p:style>
+          <a:lnRef idx="2">
+            <a:schemeClr val="accent1"/>
+          </a:lnRef>
+          <a:fillRef idx="0">
+            <a:srgbClr val="FFFFFF"/>
+          </a:fillRef>
+          <a:effectRef idx="0">
+            <a:srgbClr val="FFFFFF"/>
+          </a:effectRef>
+          <a:fontRef idx="minor">
+            <a:schemeClr val="tx1"/>
+          </a:fontRef>
+        </p:style>
+      </p:cxnSp>
+      <p:cxnSp>
+        <p:nvCxnSpPr>
+          <p:cNvPr id="180" name="直接箭头连接符 179"/>
+          <p:cNvCxnSpPr/>
+          <p:nvPr/>
+        </p:nvCxnSpPr>
+        <p:spPr>
+          <a:xfrm>
+            <a:off x="8259445" y="1838960"/>
+            <a:ext cx="201295" cy="0"/>
+          </a:xfrm>
+          <a:prstGeom prst="straightConnector1">
+            <a:avLst/>
+          </a:prstGeom>
+          <a:ln>
+            <a:solidFill>
+              <a:schemeClr val="tx1"/>
+            </a:solidFill>
+            <a:tailEnd type="arrow"/>
+          </a:ln>
+        </p:spPr>
+        <p:style>
+          <a:lnRef idx="2">
+            <a:schemeClr val="accent1"/>
+          </a:lnRef>
+          <a:fillRef idx="0">
+            <a:srgbClr val="FFFFFF"/>
+          </a:fillRef>
+          <a:effectRef idx="0">
+            <a:srgbClr val="FFFFFF"/>
+          </a:effectRef>
+          <a:fontRef idx="minor">
+            <a:schemeClr val="tx1"/>
+          </a:fontRef>
+        </p:style>
+      </p:cxnSp>
+      <p:cxnSp>
+        <p:nvCxnSpPr>
+          <p:cNvPr id="181" name="肘形连接符 180"/>
+          <p:cNvCxnSpPr>
+            <a:stCxn id="174" idx="3"/>
+            <a:endCxn id="176" idx="0"/>
+          </p:cNvCxnSpPr>
+          <p:nvPr/>
+        </p:nvCxnSpPr>
+        <p:spPr>
+          <a:xfrm>
+            <a:off x="8475345" y="989330"/>
+            <a:ext cx="143510" cy="697865"/>
+          </a:xfrm>
+          <a:prstGeom prst="bentConnector2">
+            <a:avLst/>
+          </a:prstGeom>
+          <a:ln>
+            <a:solidFill>
+              <a:schemeClr val="tx1"/>
+            </a:solidFill>
+            <a:tailEnd type="arrow"/>
+          </a:ln>
+        </p:spPr>
+        <p:style>
+          <a:lnRef idx="2">
+            <a:schemeClr val="accent1"/>
+          </a:lnRef>
+          <a:fillRef idx="0">
+            <a:srgbClr val="FFFFFF"/>
+          </a:fillRef>
+          <a:effectRef idx="0">
+            <a:srgbClr val="FFFFFF"/>
+          </a:effectRef>
+          <a:fontRef idx="minor">
+            <a:schemeClr val="tx1"/>
+          </a:fontRef>
+        </p:style>
+      </p:cxnSp>
+      <p:sp>
+        <p:nvSpPr>
+          <p:cNvPr id="183" name="圆角矩形 182"/>
+          <p:cNvSpPr/>
+          <p:nvPr/>
+        </p:nvSpPr>
+        <p:spPr>
+          <a:xfrm rot="5400000">
+            <a:off x="8648065" y="805815"/>
+            <a:ext cx="818515" cy="377825"/>
+          </a:xfrm>
+          <a:prstGeom prst="roundRect">
+            <a:avLst/>
+          </a:prstGeom>
+          <a:solidFill>
+            <a:schemeClr val="accent3">
+              <a:alpha val="50000"/>
+            </a:schemeClr>
+          </a:solidFill>
+          <a:ln>
+            <a:solidFill>
+              <a:schemeClr val="tx1"/>
+            </a:solidFill>
+          </a:ln>
+        </p:spPr>
+        <p:style>
+          <a:lnRef idx="2">
+            <a:schemeClr val="accent1">
+              <a:lumMod val="75000"/>
+            </a:schemeClr>
+          </a:lnRef>
+          <a:fillRef idx="1">
+            <a:schemeClr val="accent1"/>
+          </a:fillRef>
+          <a:effectRef idx="0">
+            <a:srgbClr val="FFFFFF"/>
+          </a:effectRef>
+          <a:fontRef idx="minor">
+            <a:schemeClr val="lt1"/>
+          </a:fontRef>
+        </p:style>
+        <p:txBody>
+          <a:bodyPr rtlCol="0" anchor="ctr"/>
+          <a:p>
+            <a:pPr algn="ctr"/>
+            <a:r>
+              <a:rPr lang="en-US" altLang="zh-CN" sz="900">
+                <a:solidFill>
+                  <a:schemeClr val="tx1"/>
+                </a:solidFill>
+                <a:latin typeface="Times New Roman" panose="02020503050405090304" charset="0"/>
+                <a:cs typeface="Times New Roman" panose="02020503050405090304" charset="0"/>
+              </a:rPr>
+              <a:t>Patch Expanding</a:t>
+            </a:r>
+            <a:endParaRPr lang="en-US" altLang="zh-CN" sz="900">
+              <a:solidFill>
+                <a:schemeClr val="tx1"/>
+              </a:solidFill>
+              <a:latin typeface="Times New Roman" panose="02020503050405090304" charset="0"/>
+              <a:cs typeface="Times New Roman" panose="02020503050405090304" charset="0"/>
+            </a:endParaRPr>
+          </a:p>
+        </p:txBody>
+      </p:sp>
+      <p:cxnSp>
+        <p:nvCxnSpPr>
+          <p:cNvPr id="184" name="肘形连接符 183"/>
+          <p:cNvCxnSpPr>
+            <a:stCxn id="176" idx="6"/>
+            <a:endCxn id="183" idx="3"/>
+          </p:cNvCxnSpPr>
+          <p:nvPr/>
+        </p:nvCxnSpPr>
+        <p:spPr>
+          <a:xfrm flipV="1">
+            <a:off x="8767445" y="1403985"/>
+            <a:ext cx="290195" cy="434975"/>
+          </a:xfrm>
+          <a:prstGeom prst="bentConnector2">
+            <a:avLst/>
+          </a:prstGeom>
+          <a:ln>
+            <a:solidFill>
+              <a:schemeClr val="tx1"/>
+            </a:solidFill>
+            <a:tailEnd type="arrow"/>
+          </a:ln>
+        </p:spPr>
+        <p:style>
+          <a:lnRef idx="2">
+            <a:schemeClr val="accent1"/>
+          </a:lnRef>
+          <a:fillRef idx="0">
+            <a:srgbClr val="FFFFFF"/>
+          </a:fillRef>
+          <a:effectRef idx="0">
+            <a:srgbClr val="FFFFFF"/>
+          </a:effectRef>
+          <a:fontRef idx="minor">
+            <a:schemeClr val="tx1"/>
+          </a:fontRef>
+        </p:style>
+      </p:cxnSp>
+      <p:cxnSp>
+        <p:nvCxnSpPr>
+          <p:cNvPr id="185" name="直接箭头连接符 184"/>
+          <p:cNvCxnSpPr>
+            <a:stCxn id="121" idx="2"/>
+            <a:endCxn id="174" idx="1"/>
+          </p:cNvCxnSpPr>
+          <p:nvPr/>
+        </p:nvCxnSpPr>
+        <p:spPr>
+          <a:xfrm>
+            <a:off x="1950085" y="983615"/>
+            <a:ext cx="5706745" cy="5715"/>
+          </a:xfrm>
+          <a:prstGeom prst="straightConnector1">
+            <a:avLst/>
+          </a:prstGeom>
+          <a:ln>
+            <a:solidFill>
+              <a:schemeClr val="tx1"/>
+            </a:solidFill>
+            <a:tailEnd type="arrow"/>
+          </a:ln>
+        </p:spPr>
+        <p:style>
+          <a:lnRef idx="2">
+            <a:schemeClr val="accent1"/>
+          </a:lnRef>
+          <a:fillRef idx="0">
+            <a:srgbClr val="FFFFFF"/>
+          </a:fillRef>
+          <a:effectRef idx="0">
+            <a:srgbClr val="FFFFFF"/>
+          </a:effectRef>
+          <a:fontRef idx="minor">
+            <a:schemeClr val="tx1"/>
+          </a:fontRef>
+        </p:style>
+      </p:cxnSp>
     </p:spTree>
     <p:custDataLst>
       <p:tags r:id="rId1"/>
@@ -6323,27 +6426,6 @@
 </file>
 
 <file path=ppt/tags/tag63.xml><?xml version="1.0" encoding="utf-8"?>
-<p:tagLst xmlns:p="http://schemas.openxmlformats.org/presentationml/2006/main">
-  <p:tag name="KSO_WM_SLIDE_ID" val="custom20205081_1"/>
-  <p:tag name="KSO_WM_TEMPLATE_SUBCATEGORY" val="19"/>
-  <p:tag name="KSO_WM_TEMPLATE_MASTER_TYPE" val="0"/>
-  <p:tag name="KSO_WM_TEMPLATE_COLOR_TYPE" val="1"/>
-  <p:tag name="KSO_WM_SLIDE_TYPE" val="title"/>
-  <p:tag name="KSO_WM_SLIDE_SUBTYPE" val="defaultBlank"/>
-  <p:tag name="KSO_WM_SLIDE_ITEM_CNT" val="0"/>
-  <p:tag name="KSO_WM_SLIDE_INDEX" val="1"/>
-  <p:tag name="KSO_WM_TAG_VERSION" val="1.0"/>
-  <p:tag name="KSO_WM_BEAUTIFY_FLAG" val="#wm#"/>
-  <p:tag name="KSO_WM_TEMPLATE_CATEGORY" val="custom"/>
-  <p:tag name="KSO_WM_TEMPLATE_INDEX" val="20205081"/>
-  <p:tag name="KSO_WM_SLIDE_LAYOUT" val="a_b"/>
-  <p:tag name="KSO_WM_SLIDE_LAYOUT_CNT" val="1_1"/>
-  <p:tag name="KSO_WM_UNIT_SHOW_EDIT_AREA_INDICATION" val="1"/>
-  <p:tag name="KSO_WM_TEMPLATE_THUMBS_INDEX" val="1、4、7、12、13、14、15、16、17、18、20、24、25、28、33、36、40、43、44"/>
-</p:tagLst>
-</file>
-
-<file path=ppt/tags/tag64.xml><?xml version="1.0" encoding="utf-8"?>
 <p:tagLst xmlns:p="http://schemas.openxmlformats.org/presentationml/2006/main">
   <p:tag name="KSO_WM_BEAUTIFY_FLAG" val="#wm#"/>
   <p:tag name="KSO_WM_TEMPLATE_CATEGORY" val="custom"/>

</xml_diff>